<commit_message>
Add a "Why revealed" slide to the slide decks
New slide 13 in the English, Urdu and Hindi decks (PPTX + PDF) showing the
Why revealed button, the report panel and the grade with Show Arabic.
Screenshots retaken from the current app.

Co-Authored-By: Claude Opus 5.5 <noreply@anthropic.com>
Claude-Session: https://claude.ai/code/session_011woVNPto2k8jKRAzvjEdfY
</commit_message>
<xml_diff>
--- a/decks/quran-word-reader-en.pptx
+++ b/decks/quran-word-reader-en.pptx
@@ -21,6 +21,7 @@
     <p:sldId id="269" r:id="rId20"/>
     <p:sldId id="270" r:id="rId21"/>
     <p:sldId id="271" r:id="rId22"/>
+    <p:sldId id="272" r:id="rId23"/>
   </p:sldIdLst>
   <p:sldSz cx="12191695" cy="6858000" type="screen4x3"/>
   <p:notesSz cx="6858000" cy="9144000"/>
@@ -5548,7 +5549,7 @@
         <p:spPr>
           <a:xfrm>
             <a:off x="1325880" y="566928"/>
-            <a:ext cx="4206240" cy="475488"/>
+            <a:ext cx="3611880" cy="475488"/>
           </a:xfrm>
           <a:prstGeom prst="rect">
             <a:avLst/>
@@ -5570,7 +5571,7 @@
                 <a:latin typeface="Calibri"/>
                 <a:cs typeface="Calibri"/>
               </a:rPr>
-              <a:t>HINDI LETTERS</a:t>
+              <a:t>WHY REVEALED</a:t>
             </a:r>
           </a:p>
         </p:txBody>
@@ -5584,7 +5585,7 @@
         <p:spPr>
           <a:xfrm>
             <a:off x="640080" y="1207008"/>
-            <a:ext cx="4937760" cy="1051560"/>
+            <a:ext cx="4343400" cy="1051560"/>
           </a:xfrm>
           <a:prstGeom prst="rect">
             <a:avLst/>
@@ -5610,7 +5611,7 @@
                 <a:latin typeface="Cambria"/>
                 <a:cs typeface="Cambria"/>
               </a:rPr>
-              <a:t>No Arabic letters yet? Start anyway.</a:t>
+              <a:t>The story behind the āyah</a:t>
             </a:r>
           </a:p>
         </p:txBody>
@@ -5624,7 +5625,7 @@
         <p:spPr>
           <a:xfrm>
             <a:off x="640080" y="2514600"/>
-            <a:ext cx="4937760" cy="3749039"/>
+            <a:ext cx="4343400" cy="3749039"/>
           </a:xfrm>
           <a:prstGeom prst="rect">
             <a:avLst/>
@@ -5653,7 +5654,7 @@
                 <a:latin typeface="Calibri"/>
                 <a:cs typeface="Calibri"/>
               </a:rPr>
-              <a:t>Every word can be shown in Hindi letters, alone or under the Arabic.</a:t>
+              <a:t>Tap 📜 Why revealed to read what happened when an āyah came down.</a:t>
             </a:r>
           </a:p>
           <a:p>
@@ -5672,44 +5673,14 @@
               <a:buChar char="•"/>
             </a:pPr>
             <a:r>
-              <a:rPr sz="1600" b="0" lang="ar-SA">
+              <a:rPr sz="1600" b="0" lang="en-US">
                 <a:solidFill>
                   <a:srgbClr val="15302E"/>
                 </a:solidFill>
                 <a:latin typeface="Calibri"/>
-                <a:cs typeface="Arial"/>
-              </a:rPr>
-              <a:t>ٱلَّذِينَ‎ </a:t>
-            </a:r>
-            <a:r>
-              <a:rPr sz="1600" b="0" lang="en-US">
-                <a:solidFill>
-                  <a:srgbClr val="15302E"/>
-                </a:solidFill>
-                <a:latin typeface="Calibri"/>
-                <a:cs typeface="Calibri"/>
-              </a:rPr>
-              <a:t>is written </a:t>
-            </a:r>
-            <a:r>
-              <a:rPr sz="1600" b="0" lang="hi-IN">
-                <a:solidFill>
-                  <a:srgbClr val="15302E"/>
-                </a:solidFill>
-                <a:latin typeface="Calibri"/>
-                <a:cs typeface="Nirmala UI"/>
-              </a:rPr>
-              <a:t>अल्लज़ी-न. </a:t>
-            </a:r>
-            <a:r>
-              <a:rPr sz="1600" b="0" lang="en-US">
-                <a:solidFill>
-                  <a:srgbClr val="15302E"/>
-                </a:solidFill>
-                <a:latin typeface="Calibri"/>
-                <a:cs typeface="Calibri"/>
-              </a:rPr>
-              <a:t>The "-" marks a short "a" that is said.</a:t>
+                <a:cs typeface="Calibri"/>
+              </a:rPr>
+              <a:t>Only authentic reports, from al-Suyūṭī's Lubāb al-Nuqūl.</a:t>
             </a:r>
           </a:p>
           <a:p>
@@ -5735,17 +5706,7 @@
                 <a:latin typeface="Calibri"/>
                 <a:cs typeface="Calibri"/>
               </a:rPr>
-              <a:t>An āyah's last word is written as read at a stop: </a:t>
-            </a:r>
-            <a:r>
-              <a:rPr sz="1600" b="0" lang="hi-IN">
-                <a:solidFill>
-                  <a:srgbClr val="15302E"/>
-                </a:solidFill>
-                <a:latin typeface="Calibri"/>
-                <a:cs typeface="Nirmala UI"/>
-              </a:rPr>
-              <a:t>लिल्मुत्तक़ीन.</a:t>
+              <a:t>Each report shows its grade, such as Ṣaḥīḥ: al-Bukhārī and Muslim.</a:t>
             </a:r>
           </a:p>
           <a:p>
@@ -5771,7 +5732,7 @@
                 <a:latin typeface="Calibri"/>
                 <a:cs typeface="Calibri"/>
               </a:rPr>
-              <a:t>Quizzes switch to Hindi letters too.</a:t>
+              <a:t>Read it in English, Urdu or Hindi. The Arabic is one tap away.</a:t>
             </a:r>
           </a:p>
         </p:txBody>
@@ -5784,8 +5745,8 @@
         </p:nvSpPr>
         <p:spPr>
           <a:xfrm>
-            <a:off x="6089903" y="621792"/>
-            <a:ext cx="2651760" cy="5038344"/>
+            <a:off x="5312664" y="941832"/>
+            <a:ext cx="2103120" cy="4163099"/>
           </a:xfrm>
           <a:prstGeom prst="roundRect">
             <a:avLst>
@@ -5824,7 +5785,7 @@
       </p:sp>
       <p:pic>
         <p:nvPicPr>
-          <p:cNvPr id="7" name="Screenshot hindi" descr="hindi"/>
+          <p:cNvPr id="7" name="Screenshot why" descr="why"/>
           <p:cNvPicPr>
             <a:picLocks noChangeAspect="1"/>
           </p:cNvPicPr>
@@ -5838,8 +5799,8 @@
         </p:blipFill>
         <p:spPr>
           <a:xfrm>
-            <a:off x="6035040" y="548640"/>
-            <a:ext cx="2651760" cy="5038344"/>
+            <a:off x="5257800" y="868680"/>
+            <a:ext cx="2103120" cy="4163099"/>
           </a:xfrm>
           <a:prstGeom prst="roundRect">
             <a:avLst>
@@ -5861,8 +5822,8 @@
         </p:nvSpPr>
         <p:spPr>
           <a:xfrm>
-            <a:off x="9015984" y="1033272"/>
-            <a:ext cx="2651760" cy="5038344"/>
+            <a:off x="7534656" y="576072"/>
+            <a:ext cx="2103120" cy="4163099"/>
           </a:xfrm>
           <a:prstGeom prst="roundRect">
             <a:avLst>
@@ -5901,7 +5862,7 @@
       </p:sp>
       <p:pic>
         <p:nvPicPr>
-          <p:cNvPr id="9" name="Screenshot hquiz" descr="hquiz"/>
+          <p:cNvPr id="9" name="Screenshot whypanel" descr="whypanel"/>
           <p:cNvPicPr>
             <a:picLocks noChangeAspect="1"/>
           </p:cNvPicPr>
@@ -5915,8 +5876,8 @@
         </p:blipFill>
         <p:spPr>
           <a:xfrm>
-            <a:off x="8961119" y="960120"/>
-            <a:ext cx="2651760" cy="5038344"/>
+            <a:off x="7479792" y="502920"/>
+            <a:ext cx="2103120" cy="4163099"/>
           </a:xfrm>
           <a:prstGeom prst="roundRect">
             <a:avLst>
@@ -5932,7 +5893,84 @@
       </p:pic>
       <p:sp>
         <p:nvSpPr>
-          <p:cNvPr id="10" name="Footer"/>
+          <p:cNvPr id="10" name="Phone shadow"/>
+          <p:cNvSpPr/>
+          <p:nvPr/>
+        </p:nvSpPr>
+        <p:spPr>
+          <a:xfrm>
+            <a:off x="9756648" y="1307592"/>
+            <a:ext cx="2103120" cy="4163099"/>
+          </a:xfrm>
+          <a:prstGeom prst="roundRect">
+            <a:avLst>
+              <a:gd name="adj" fmla="val 6000"/>
+            </a:avLst>
+          </a:prstGeom>
+          <a:solidFill>
+            <a:srgbClr val="C9D3D0"/>
+          </a:solidFill>
+          <a:ln>
+            <a:noFill/>
+          </a:ln>
+          <a:effectLst/>
+        </p:spPr>
+        <p:style>
+          <a:lnRef idx="1">
+            <a:schemeClr val="accent1"/>
+          </a:lnRef>
+          <a:fillRef idx="3">
+            <a:schemeClr val="accent1"/>
+          </a:fillRef>
+          <a:effectRef idx="2">
+            <a:schemeClr val="accent1"/>
+          </a:effectRef>
+          <a:fontRef idx="minor">
+            <a:schemeClr val="lt1"/>
+          </a:fontRef>
+        </p:style>
+        <p:txBody>
+          <a:bodyPr rtlCol="0" anchor="ctr"/>
+          <a:lstStyle/>
+          <a:p>
+            <a:pPr algn="ctr"/>
+          </a:p>
+        </p:txBody>
+      </p:sp>
+      <p:pic>
+        <p:nvPicPr>
+          <p:cNvPr id="11" name="Screenshot whyar" descr="whyar"/>
+          <p:cNvPicPr>
+            <a:picLocks noChangeAspect="1"/>
+          </p:cNvPicPr>
+          <p:nvPr/>
+        </p:nvPicPr>
+        <p:blipFill>
+          <a:blip r:embed="rId4"/>
+          <a:stretch>
+            <a:fillRect/>
+          </a:stretch>
+        </p:blipFill>
+        <p:spPr>
+          <a:xfrm>
+            <a:off x="9701784" y="1234440"/>
+            <a:ext cx="2103120" cy="4163099"/>
+          </a:xfrm>
+          <a:prstGeom prst="roundRect">
+            <a:avLst>
+              <a:gd name="adj" fmla="val 6000"/>
+            </a:avLst>
+          </a:prstGeom>
+          <a:ln w="28575">
+            <a:solidFill>
+              <a:srgbClr val="15302E"/>
+            </a:solidFill>
+          </a:ln>
+        </p:spPr>
+      </p:pic>
+      <p:sp>
+        <p:nvSpPr>
+          <p:cNvPr id="12" name="Footer"/>
           <p:cNvSpPr txBox="1"/>
           <p:nvPr/>
         </p:nvSpPr>
@@ -5968,7 +6006,7 @@
       </p:sp>
       <p:sp>
         <p:nvSpPr>
-          <p:cNvPr id="11" name="Slide number"/>
+          <p:cNvPr id="13" name="Slide number"/>
           <p:cNvSpPr txBox="1"/>
           <p:nvPr/>
         </p:nvSpPr>
@@ -6091,7 +6129,7 @@
         <p:spPr>
           <a:xfrm>
             <a:off x="1325880" y="566928"/>
-            <a:ext cx="3749040" cy="475488"/>
+            <a:ext cx="4206240" cy="475488"/>
           </a:xfrm>
           <a:prstGeom prst="rect">
             <a:avLst/>
@@ -6113,7 +6151,7 @@
                 <a:latin typeface="Calibri"/>
                 <a:cs typeface="Calibri"/>
               </a:rPr>
-              <a:t>ANYWHERE</a:t>
+              <a:t>HINDI LETTERS</a:t>
             </a:r>
           </a:p>
         </p:txBody>
@@ -6127,7 +6165,7 @@
         <p:spPr>
           <a:xfrm>
             <a:off x="640080" y="1207008"/>
-            <a:ext cx="4480560" cy="1051560"/>
+            <a:ext cx="4937760" cy="1051560"/>
           </a:xfrm>
           <a:prstGeom prst="rect">
             <a:avLst/>
@@ -6153,7 +6191,7 @@
                 <a:latin typeface="Cambria"/>
                 <a:cs typeface="Cambria"/>
               </a:rPr>
-              <a:t>On your phone, tablet or computer</a:t>
+              <a:t>No Arabic letters yet? Start anyway.</a:t>
             </a:r>
           </a:p>
         </p:txBody>
@@ -6167,7 +6205,7 @@
         <p:spPr>
           <a:xfrm>
             <a:off x="640080" y="2514600"/>
-            <a:ext cx="4480560" cy="3749039"/>
+            <a:ext cx="4937760" cy="3749039"/>
           </a:xfrm>
           <a:prstGeom prst="rect">
             <a:avLst/>
@@ -6196,7 +6234,7 @@
                 <a:latin typeface="Calibri"/>
                 <a:cs typeface="Calibri"/>
               </a:rPr>
-              <a:t>Install it once and read anywhere, even without internet.</a:t>
+              <a:t>Every word can be shown in Hindi letters, alone or under the Arabic.</a:t>
             </a:r>
           </a:p>
           <a:p>
@@ -6215,6 +6253,16 @@
               <a:buChar char="•"/>
             </a:pPr>
             <a:r>
+              <a:rPr sz="1600" b="0" lang="ar-SA">
+                <a:solidFill>
+                  <a:srgbClr val="15302E"/>
+                </a:solidFill>
+                <a:latin typeface="Calibri"/>
+                <a:cs typeface="Arial"/>
+              </a:rPr>
+              <a:t>ٱلَّذِينَ‎ </a:t>
+            </a:r>
+            <a:r>
               <a:rPr sz="1600" b="0" lang="en-US">
                 <a:solidFill>
                   <a:srgbClr val="15302E"/>
@@ -6222,7 +6270,27 @@
                 <a:latin typeface="Calibri"/>
                 <a:cs typeface="Calibri"/>
               </a:rPr>
-              <a:t>Works offline after the first visit.</a:t>
+              <a:t>is written </a:t>
+            </a:r>
+            <a:r>
+              <a:rPr sz="1600" b="0" lang="hi-IN">
+                <a:solidFill>
+                  <a:srgbClr val="15302E"/>
+                </a:solidFill>
+                <a:latin typeface="Calibri"/>
+                <a:cs typeface="Nirmala UI"/>
+              </a:rPr>
+              <a:t>अल्लज़ी-न. </a:t>
+            </a:r>
+            <a:r>
+              <a:rPr sz="1600" b="0" lang="en-US">
+                <a:solidFill>
+                  <a:srgbClr val="15302E"/>
+                </a:solidFill>
+                <a:latin typeface="Calibri"/>
+                <a:cs typeface="Calibri"/>
+              </a:rPr>
+              <a:t>The "-" marks a short "a" that is said.</a:t>
             </a:r>
           </a:p>
           <a:p>
@@ -6248,7 +6316,17 @@
                 <a:latin typeface="Calibri"/>
                 <a:cs typeface="Calibri"/>
               </a:rPr>
-              <a:t>Light or dark, whatever the phone's setting.</a:t>
+              <a:t>An āyah's last word is written as read at a stop: </a:t>
+            </a:r>
+            <a:r>
+              <a:rPr sz="1600" b="0" lang="hi-IN">
+                <a:solidFill>
+                  <a:srgbClr val="15302E"/>
+                </a:solidFill>
+                <a:latin typeface="Calibri"/>
+                <a:cs typeface="Nirmala UI"/>
+              </a:rPr>
+              <a:t>लिल्मुत्तक़ीन.</a:t>
             </a:r>
           </a:p>
           <a:p>
@@ -6274,25 +6352,25 @@
                 <a:latin typeface="Calibri"/>
                 <a:cs typeface="Calibri"/>
               </a:rPr>
-              <a:t>On a computer the word card opens beside the page.</a:t>
-            </a:r>
-          </a:p>
-        </p:txBody>
-      </p:sp>
-      <p:sp>
-        <p:nvSpPr>
-          <p:cNvPr id="6" name="Window shadow"/>
+              <a:t>Quizzes switch to Hindi letters too.</a:t>
+            </a:r>
+          </a:p>
+        </p:txBody>
+      </p:sp>
+      <p:sp>
+        <p:nvSpPr>
+          <p:cNvPr id="6" name="Phone shadow"/>
           <p:cNvSpPr/>
           <p:nvPr/>
         </p:nvSpPr>
         <p:spPr>
           <a:xfrm>
-            <a:off x="5504688" y="996696"/>
-            <a:ext cx="5120640" cy="3295903"/>
+            <a:off x="6089903" y="621792"/>
+            <a:ext cx="2651760" cy="5038344"/>
           </a:xfrm>
           <a:prstGeom prst="roundRect">
             <a:avLst>
-              <a:gd name="adj" fmla="val 3000"/>
+              <a:gd name="adj" fmla="val 6000"/>
             </a:avLst>
           </a:prstGeom>
           <a:solidFill>
@@ -6325,187 +6403,9 @@
           </a:p>
         </p:txBody>
       </p:sp>
-      <p:sp>
-        <p:nvSpPr>
-          <p:cNvPr id="7" name="Window frame"/>
-          <p:cNvSpPr/>
-          <p:nvPr/>
-        </p:nvSpPr>
-        <p:spPr>
-          <a:xfrm>
-            <a:off x="5440680" y="914400"/>
-            <a:ext cx="5120640" cy="3295903"/>
-          </a:xfrm>
-          <a:prstGeom prst="roundRect">
-            <a:avLst>
-              <a:gd name="adj" fmla="val 3000"/>
-            </a:avLst>
-          </a:prstGeom>
-          <a:solidFill>
-            <a:srgbClr val="15302E"/>
-          </a:solidFill>
-          <a:ln>
-            <a:noFill/>
-          </a:ln>
-          <a:effectLst/>
-        </p:spPr>
-        <p:style>
-          <a:lnRef idx="1">
-            <a:schemeClr val="accent1"/>
-          </a:lnRef>
-          <a:fillRef idx="3">
-            <a:schemeClr val="accent1"/>
-          </a:fillRef>
-          <a:effectRef idx="2">
-            <a:schemeClr val="accent1"/>
-          </a:effectRef>
-          <a:fontRef idx="minor">
-            <a:schemeClr val="lt1"/>
-          </a:fontRef>
-        </p:style>
-        <p:txBody>
-          <a:bodyPr rtlCol="0" anchor="ctr"/>
-          <a:lstStyle/>
-          <a:p>
-            <a:pPr algn="ctr"/>
-          </a:p>
-        </p:txBody>
-      </p:sp>
-      <p:sp>
-        <p:nvSpPr>
-          <p:cNvPr id="8" name="Window dot"/>
-          <p:cNvSpPr/>
-          <p:nvPr/>
-        </p:nvSpPr>
-        <p:spPr>
-          <a:xfrm>
-            <a:off x="5568696" y="987552"/>
-            <a:ext cx="91440" cy="91440"/>
-          </a:xfrm>
-          <a:prstGeom prst="ellipse">
-            <a:avLst/>
-          </a:prstGeom>
-          <a:solidFill>
-            <a:srgbClr val="EF8A8A"/>
-          </a:solidFill>
-          <a:ln>
-            <a:noFill/>
-          </a:ln>
-          <a:effectLst/>
-        </p:spPr>
-        <p:style>
-          <a:lnRef idx="1">
-            <a:schemeClr val="accent1"/>
-          </a:lnRef>
-          <a:fillRef idx="3">
-            <a:schemeClr val="accent1"/>
-          </a:fillRef>
-          <a:effectRef idx="2">
-            <a:schemeClr val="accent1"/>
-          </a:effectRef>
-          <a:fontRef idx="minor">
-            <a:schemeClr val="lt1"/>
-          </a:fontRef>
-        </p:style>
-        <p:txBody>
-          <a:bodyPr rtlCol="0" anchor="ctr"/>
-          <a:lstStyle/>
-          <a:p>
-            <a:pPr algn="ctr"/>
-          </a:p>
-        </p:txBody>
-      </p:sp>
-      <p:sp>
-        <p:nvSpPr>
-          <p:cNvPr id="9" name="Window dot"/>
-          <p:cNvSpPr/>
-          <p:nvPr/>
-        </p:nvSpPr>
-        <p:spPr>
-          <a:xfrm>
-            <a:off x="5733288" y="987552"/>
-            <a:ext cx="91440" cy="91440"/>
-          </a:xfrm>
-          <a:prstGeom prst="ellipse">
-            <a:avLst/>
-          </a:prstGeom>
-          <a:solidFill>
-            <a:srgbClr val="E9A227"/>
-          </a:solidFill>
-          <a:ln>
-            <a:noFill/>
-          </a:ln>
-          <a:effectLst/>
-        </p:spPr>
-        <p:style>
-          <a:lnRef idx="1">
-            <a:schemeClr val="accent1"/>
-          </a:lnRef>
-          <a:fillRef idx="3">
-            <a:schemeClr val="accent1"/>
-          </a:fillRef>
-          <a:effectRef idx="2">
-            <a:schemeClr val="accent1"/>
-          </a:effectRef>
-          <a:fontRef idx="minor">
-            <a:schemeClr val="lt1"/>
-          </a:fontRef>
-        </p:style>
-        <p:txBody>
-          <a:bodyPr rtlCol="0" anchor="ctr"/>
-          <a:lstStyle/>
-          <a:p>
-            <a:pPr algn="ctr"/>
-          </a:p>
-        </p:txBody>
-      </p:sp>
-      <p:sp>
-        <p:nvSpPr>
-          <p:cNvPr id="10" name="Window dot"/>
-          <p:cNvSpPr/>
-          <p:nvPr/>
-        </p:nvSpPr>
-        <p:spPr>
-          <a:xfrm>
-            <a:off x="5897880" y="987552"/>
-            <a:ext cx="91440" cy="91440"/>
-          </a:xfrm>
-          <a:prstGeom prst="ellipse">
-            <a:avLst/>
-          </a:prstGeom>
-          <a:solidFill>
-            <a:srgbClr val="6CC38F"/>
-          </a:solidFill>
-          <a:ln>
-            <a:noFill/>
-          </a:ln>
-          <a:effectLst/>
-        </p:spPr>
-        <p:style>
-          <a:lnRef idx="1">
-            <a:schemeClr val="accent1"/>
-          </a:lnRef>
-          <a:fillRef idx="3">
-            <a:schemeClr val="accent1"/>
-          </a:fillRef>
-          <a:effectRef idx="2">
-            <a:schemeClr val="accent1"/>
-          </a:effectRef>
-          <a:fontRef idx="minor">
-            <a:schemeClr val="lt1"/>
-          </a:fontRef>
-        </p:style>
-        <p:txBody>
-          <a:bodyPr rtlCol="0" anchor="ctr"/>
-          <a:lstStyle/>
-          <a:p>
-            <a:pPr algn="ctr"/>
-          </a:p>
-        </p:txBody>
-      </p:sp>
       <p:pic>
         <p:nvPicPr>
-          <p:cNvPr id="11" name="Screenshot desk" descr="desk"/>
+          <p:cNvPr id="7" name="Screenshot hindi" descr="hindi"/>
           <p:cNvPicPr>
             <a:picLocks noChangeAspect="1"/>
           </p:cNvPicPr>
@@ -6519,24 +6419,31 @@
         </p:blipFill>
         <p:spPr>
           <a:xfrm>
-            <a:off x="5468112" y="1152144"/>
-            <a:ext cx="5065776" cy="3021583"/>
-          </a:xfrm>
-          <a:prstGeom prst="rect">
-            <a:avLst/>
-          </a:prstGeom>
+            <a:off x="6035040" y="548640"/>
+            <a:ext cx="2651760" cy="5038344"/>
+          </a:xfrm>
+          <a:prstGeom prst="roundRect">
+            <a:avLst>
+              <a:gd name="adj" fmla="val 6000"/>
+            </a:avLst>
+          </a:prstGeom>
+          <a:ln w="28575">
+            <a:solidFill>
+              <a:srgbClr val="15302E"/>
+            </a:solidFill>
+          </a:ln>
         </p:spPr>
       </p:pic>
       <p:sp>
         <p:nvSpPr>
-          <p:cNvPr id="12" name="Phone shadow"/>
+          <p:cNvPr id="8" name="Phone shadow"/>
           <p:cNvSpPr/>
           <p:nvPr/>
         </p:nvSpPr>
         <p:spPr>
           <a:xfrm>
-            <a:off x="9701784" y="2221992"/>
-            <a:ext cx="1920240" cy="3801090"/>
+            <a:off x="9015984" y="1033272"/>
+            <a:ext cx="2651760" cy="5038344"/>
           </a:xfrm>
           <a:prstGeom prst="roundRect">
             <a:avLst>
@@ -6575,7 +6482,7 @@
       </p:sp>
       <p:pic>
         <p:nvPicPr>
-          <p:cNvPr id="13" name="Screenshot dark" descr="dark"/>
+          <p:cNvPr id="9" name="Screenshot hquiz" descr="hquiz"/>
           <p:cNvPicPr>
             <a:picLocks noChangeAspect="1"/>
           </p:cNvPicPr>
@@ -6589,8 +6496,8 @@
         </p:blipFill>
         <p:spPr>
           <a:xfrm>
-            <a:off x="9646920" y="2148840"/>
-            <a:ext cx="1920240" cy="3801090"/>
+            <a:off x="8961119" y="960120"/>
+            <a:ext cx="2651760" cy="5038344"/>
           </a:xfrm>
           <a:prstGeom prst="roundRect">
             <a:avLst>
@@ -6606,7 +6513,7 @@
       </p:pic>
       <p:sp>
         <p:nvSpPr>
-          <p:cNvPr id="14" name="Footer"/>
+          <p:cNvPr id="10" name="Footer"/>
           <p:cNvSpPr txBox="1"/>
           <p:nvPr/>
         </p:nvSpPr>
@@ -6642,7 +6549,7 @@
       </p:sp>
       <p:sp>
         <p:nvSpPr>
-          <p:cNvPr id="15" name="Slide number"/>
+          <p:cNvPr id="11" name="Slide number"/>
           <p:cNvSpPr txBox="1"/>
           <p:nvPr/>
         </p:nvSpPr>
@@ -6765,6 +6672,680 @@
         <p:spPr>
           <a:xfrm>
             <a:off x="1325880" y="566928"/>
+            <a:ext cx="3749040" cy="475488"/>
+          </a:xfrm>
+          <a:prstGeom prst="rect">
+            <a:avLst/>
+          </a:prstGeom>
+          <a:noFill/>
+        </p:spPr>
+        <p:txBody>
+          <a:bodyPr wrap="square" anchor="ctr" lIns="0" rIns="0" tIns="0" bIns="0">
+            <a:spAutoFit/>
+          </a:bodyPr>
+          <a:lstStyle/>
+          <a:p>
+            <a:pPr algn="l"/>
+            <a:r>
+              <a:rPr sz="1300" b="1" lang="en-US">
+                <a:solidFill>
+                  <a:srgbClr val="B8740F"/>
+                </a:solidFill>
+                <a:latin typeface="Calibri"/>
+                <a:cs typeface="Calibri"/>
+              </a:rPr>
+              <a:t>ANYWHERE</a:t>
+            </a:r>
+          </a:p>
+        </p:txBody>
+      </p:sp>
+      <p:sp>
+        <p:nvSpPr>
+          <p:cNvPr id="4" name="Title"/>
+          <p:cNvSpPr txBox="1"/>
+          <p:nvPr/>
+        </p:nvSpPr>
+        <p:spPr>
+          <a:xfrm>
+            <a:off x="640080" y="1207008"/>
+            <a:ext cx="4480560" cy="1051560"/>
+          </a:xfrm>
+          <a:prstGeom prst="rect">
+            <a:avLst/>
+          </a:prstGeom>
+          <a:noFill/>
+        </p:spPr>
+        <p:txBody>
+          <a:bodyPr wrap="square" anchor="t" lIns="0" rIns="0" tIns="0" bIns="0">
+            <a:spAutoFit/>
+          </a:bodyPr>
+          <a:lstStyle/>
+          <a:p>
+            <a:pPr algn="l">
+              <a:lnSpc>
+                <a:spcPct val="95000"/>
+              </a:lnSpc>
+            </a:pPr>
+            <a:r>
+              <a:rPr sz="3400" b="1" lang="en-US">
+                <a:solidFill>
+                  <a:srgbClr val="15302E"/>
+                </a:solidFill>
+                <a:latin typeface="Cambria"/>
+                <a:cs typeface="Cambria"/>
+              </a:rPr>
+              <a:t>On your phone, tablet or computer</a:t>
+            </a:r>
+          </a:p>
+        </p:txBody>
+      </p:sp>
+      <p:sp>
+        <p:nvSpPr>
+          <p:cNvPr id="5" name="Points"/>
+          <p:cNvSpPr txBox="1"/>
+          <p:nvPr/>
+        </p:nvSpPr>
+        <p:spPr>
+          <a:xfrm>
+            <a:off x="640080" y="2514600"/>
+            <a:ext cx="4480560" cy="3749039"/>
+          </a:xfrm>
+          <a:prstGeom prst="rect">
+            <a:avLst/>
+          </a:prstGeom>
+          <a:noFill/>
+        </p:spPr>
+        <p:txBody>
+          <a:bodyPr wrap="square" anchor="t" lIns="0" rIns="0" tIns="0" bIns="0">
+            <a:spAutoFit/>
+          </a:bodyPr>
+          <a:lstStyle/>
+          <a:p>
+            <a:pPr algn="l">
+              <a:lnSpc>
+                <a:spcPct val="105000"/>
+              </a:lnSpc>
+              <a:spcAft>
+                <a:spcPts val="1400"/>
+              </a:spcAft>
+            </a:pPr>
+            <a:r>
+              <a:rPr sz="1800" b="1" lang="en-US">
+                <a:solidFill>
+                  <a:srgbClr val="1F6F62"/>
+                </a:solidFill>
+                <a:latin typeface="Calibri"/>
+                <a:cs typeface="Calibri"/>
+              </a:rPr>
+              <a:t>Install it once and read anywhere, even without internet.</a:t>
+            </a:r>
+          </a:p>
+          <a:p>
+            <a:pPr algn="l" marL="292608" indent="-292608">
+              <a:lnSpc>
+                <a:spcPct val="105000"/>
+              </a:lnSpc>
+              <a:spcAft>
+                <a:spcPts val="900"/>
+              </a:spcAft>
+              <a:buClr>
+                <a:srgbClr val="E9A227"/>
+              </a:buClr>
+              <a:buSzPct val="110000"/>
+              <a:buFont typeface="Arial"/>
+              <a:buChar char="•"/>
+            </a:pPr>
+            <a:r>
+              <a:rPr sz="1600" b="0" lang="en-US">
+                <a:solidFill>
+                  <a:srgbClr val="15302E"/>
+                </a:solidFill>
+                <a:latin typeface="Calibri"/>
+                <a:cs typeface="Calibri"/>
+              </a:rPr>
+              <a:t>Works offline after the first visit.</a:t>
+            </a:r>
+          </a:p>
+          <a:p>
+            <a:pPr algn="l" marL="292608" indent="-292608">
+              <a:lnSpc>
+                <a:spcPct val="105000"/>
+              </a:lnSpc>
+              <a:spcAft>
+                <a:spcPts val="900"/>
+              </a:spcAft>
+              <a:buClr>
+                <a:srgbClr val="E9A227"/>
+              </a:buClr>
+              <a:buSzPct val="110000"/>
+              <a:buFont typeface="Arial"/>
+              <a:buChar char="•"/>
+            </a:pPr>
+            <a:r>
+              <a:rPr sz="1600" b="0" lang="en-US">
+                <a:solidFill>
+                  <a:srgbClr val="15302E"/>
+                </a:solidFill>
+                <a:latin typeface="Calibri"/>
+                <a:cs typeface="Calibri"/>
+              </a:rPr>
+              <a:t>Light or dark, whatever the phone's setting.</a:t>
+            </a:r>
+          </a:p>
+          <a:p>
+            <a:pPr algn="l" marL="292608" indent="-292608">
+              <a:lnSpc>
+                <a:spcPct val="105000"/>
+              </a:lnSpc>
+              <a:spcAft>
+                <a:spcPts val="900"/>
+              </a:spcAft>
+              <a:buClr>
+                <a:srgbClr val="E9A227"/>
+              </a:buClr>
+              <a:buSzPct val="110000"/>
+              <a:buFont typeface="Arial"/>
+              <a:buChar char="•"/>
+            </a:pPr>
+            <a:r>
+              <a:rPr sz="1600" b="0" lang="en-US">
+                <a:solidFill>
+                  <a:srgbClr val="15302E"/>
+                </a:solidFill>
+                <a:latin typeface="Calibri"/>
+                <a:cs typeface="Calibri"/>
+              </a:rPr>
+              <a:t>On a computer the word card opens beside the page.</a:t>
+            </a:r>
+          </a:p>
+        </p:txBody>
+      </p:sp>
+      <p:sp>
+        <p:nvSpPr>
+          <p:cNvPr id="6" name="Window shadow"/>
+          <p:cNvSpPr/>
+          <p:nvPr/>
+        </p:nvSpPr>
+        <p:spPr>
+          <a:xfrm>
+            <a:off x="5504688" y="996696"/>
+            <a:ext cx="5120640" cy="3295903"/>
+          </a:xfrm>
+          <a:prstGeom prst="roundRect">
+            <a:avLst>
+              <a:gd name="adj" fmla="val 3000"/>
+            </a:avLst>
+          </a:prstGeom>
+          <a:solidFill>
+            <a:srgbClr val="C9D3D0"/>
+          </a:solidFill>
+          <a:ln>
+            <a:noFill/>
+          </a:ln>
+          <a:effectLst/>
+        </p:spPr>
+        <p:style>
+          <a:lnRef idx="1">
+            <a:schemeClr val="accent1"/>
+          </a:lnRef>
+          <a:fillRef idx="3">
+            <a:schemeClr val="accent1"/>
+          </a:fillRef>
+          <a:effectRef idx="2">
+            <a:schemeClr val="accent1"/>
+          </a:effectRef>
+          <a:fontRef idx="minor">
+            <a:schemeClr val="lt1"/>
+          </a:fontRef>
+        </p:style>
+        <p:txBody>
+          <a:bodyPr rtlCol="0" anchor="ctr"/>
+          <a:lstStyle/>
+          <a:p>
+            <a:pPr algn="ctr"/>
+          </a:p>
+        </p:txBody>
+      </p:sp>
+      <p:sp>
+        <p:nvSpPr>
+          <p:cNvPr id="7" name="Window frame"/>
+          <p:cNvSpPr/>
+          <p:nvPr/>
+        </p:nvSpPr>
+        <p:spPr>
+          <a:xfrm>
+            <a:off x="5440680" y="914400"/>
+            <a:ext cx="5120640" cy="3295903"/>
+          </a:xfrm>
+          <a:prstGeom prst="roundRect">
+            <a:avLst>
+              <a:gd name="adj" fmla="val 3000"/>
+            </a:avLst>
+          </a:prstGeom>
+          <a:solidFill>
+            <a:srgbClr val="15302E"/>
+          </a:solidFill>
+          <a:ln>
+            <a:noFill/>
+          </a:ln>
+          <a:effectLst/>
+        </p:spPr>
+        <p:style>
+          <a:lnRef idx="1">
+            <a:schemeClr val="accent1"/>
+          </a:lnRef>
+          <a:fillRef idx="3">
+            <a:schemeClr val="accent1"/>
+          </a:fillRef>
+          <a:effectRef idx="2">
+            <a:schemeClr val="accent1"/>
+          </a:effectRef>
+          <a:fontRef idx="minor">
+            <a:schemeClr val="lt1"/>
+          </a:fontRef>
+        </p:style>
+        <p:txBody>
+          <a:bodyPr rtlCol="0" anchor="ctr"/>
+          <a:lstStyle/>
+          <a:p>
+            <a:pPr algn="ctr"/>
+          </a:p>
+        </p:txBody>
+      </p:sp>
+      <p:sp>
+        <p:nvSpPr>
+          <p:cNvPr id="8" name="Window dot"/>
+          <p:cNvSpPr/>
+          <p:nvPr/>
+        </p:nvSpPr>
+        <p:spPr>
+          <a:xfrm>
+            <a:off x="5568696" y="987552"/>
+            <a:ext cx="91440" cy="91440"/>
+          </a:xfrm>
+          <a:prstGeom prst="ellipse">
+            <a:avLst/>
+          </a:prstGeom>
+          <a:solidFill>
+            <a:srgbClr val="EF8A8A"/>
+          </a:solidFill>
+          <a:ln>
+            <a:noFill/>
+          </a:ln>
+          <a:effectLst/>
+        </p:spPr>
+        <p:style>
+          <a:lnRef idx="1">
+            <a:schemeClr val="accent1"/>
+          </a:lnRef>
+          <a:fillRef idx="3">
+            <a:schemeClr val="accent1"/>
+          </a:fillRef>
+          <a:effectRef idx="2">
+            <a:schemeClr val="accent1"/>
+          </a:effectRef>
+          <a:fontRef idx="minor">
+            <a:schemeClr val="lt1"/>
+          </a:fontRef>
+        </p:style>
+        <p:txBody>
+          <a:bodyPr rtlCol="0" anchor="ctr"/>
+          <a:lstStyle/>
+          <a:p>
+            <a:pPr algn="ctr"/>
+          </a:p>
+        </p:txBody>
+      </p:sp>
+      <p:sp>
+        <p:nvSpPr>
+          <p:cNvPr id="9" name="Window dot"/>
+          <p:cNvSpPr/>
+          <p:nvPr/>
+        </p:nvSpPr>
+        <p:spPr>
+          <a:xfrm>
+            <a:off x="5733288" y="987552"/>
+            <a:ext cx="91440" cy="91440"/>
+          </a:xfrm>
+          <a:prstGeom prst="ellipse">
+            <a:avLst/>
+          </a:prstGeom>
+          <a:solidFill>
+            <a:srgbClr val="E9A227"/>
+          </a:solidFill>
+          <a:ln>
+            <a:noFill/>
+          </a:ln>
+          <a:effectLst/>
+        </p:spPr>
+        <p:style>
+          <a:lnRef idx="1">
+            <a:schemeClr val="accent1"/>
+          </a:lnRef>
+          <a:fillRef idx="3">
+            <a:schemeClr val="accent1"/>
+          </a:fillRef>
+          <a:effectRef idx="2">
+            <a:schemeClr val="accent1"/>
+          </a:effectRef>
+          <a:fontRef idx="minor">
+            <a:schemeClr val="lt1"/>
+          </a:fontRef>
+        </p:style>
+        <p:txBody>
+          <a:bodyPr rtlCol="0" anchor="ctr"/>
+          <a:lstStyle/>
+          <a:p>
+            <a:pPr algn="ctr"/>
+          </a:p>
+        </p:txBody>
+      </p:sp>
+      <p:sp>
+        <p:nvSpPr>
+          <p:cNvPr id="10" name="Window dot"/>
+          <p:cNvSpPr/>
+          <p:nvPr/>
+        </p:nvSpPr>
+        <p:spPr>
+          <a:xfrm>
+            <a:off x="5897880" y="987552"/>
+            <a:ext cx="91440" cy="91440"/>
+          </a:xfrm>
+          <a:prstGeom prst="ellipse">
+            <a:avLst/>
+          </a:prstGeom>
+          <a:solidFill>
+            <a:srgbClr val="6CC38F"/>
+          </a:solidFill>
+          <a:ln>
+            <a:noFill/>
+          </a:ln>
+          <a:effectLst/>
+        </p:spPr>
+        <p:style>
+          <a:lnRef idx="1">
+            <a:schemeClr val="accent1"/>
+          </a:lnRef>
+          <a:fillRef idx="3">
+            <a:schemeClr val="accent1"/>
+          </a:fillRef>
+          <a:effectRef idx="2">
+            <a:schemeClr val="accent1"/>
+          </a:effectRef>
+          <a:fontRef idx="minor">
+            <a:schemeClr val="lt1"/>
+          </a:fontRef>
+        </p:style>
+        <p:txBody>
+          <a:bodyPr rtlCol="0" anchor="ctr"/>
+          <a:lstStyle/>
+          <a:p>
+            <a:pPr algn="ctr"/>
+          </a:p>
+        </p:txBody>
+      </p:sp>
+      <p:pic>
+        <p:nvPicPr>
+          <p:cNvPr id="11" name="Screenshot desk" descr="desk"/>
+          <p:cNvPicPr>
+            <a:picLocks noChangeAspect="1"/>
+          </p:cNvPicPr>
+          <p:nvPr/>
+        </p:nvPicPr>
+        <p:blipFill>
+          <a:blip r:embed="rId2"/>
+          <a:stretch>
+            <a:fillRect/>
+          </a:stretch>
+        </p:blipFill>
+        <p:spPr>
+          <a:xfrm>
+            <a:off x="5468112" y="1152144"/>
+            <a:ext cx="5065776" cy="3021583"/>
+          </a:xfrm>
+          <a:prstGeom prst="rect">
+            <a:avLst/>
+          </a:prstGeom>
+        </p:spPr>
+      </p:pic>
+      <p:sp>
+        <p:nvSpPr>
+          <p:cNvPr id="12" name="Phone shadow"/>
+          <p:cNvSpPr/>
+          <p:nvPr/>
+        </p:nvSpPr>
+        <p:spPr>
+          <a:xfrm>
+            <a:off x="9701784" y="2221992"/>
+            <a:ext cx="1920240" cy="3801090"/>
+          </a:xfrm>
+          <a:prstGeom prst="roundRect">
+            <a:avLst>
+              <a:gd name="adj" fmla="val 6000"/>
+            </a:avLst>
+          </a:prstGeom>
+          <a:solidFill>
+            <a:srgbClr val="C9D3D0"/>
+          </a:solidFill>
+          <a:ln>
+            <a:noFill/>
+          </a:ln>
+          <a:effectLst/>
+        </p:spPr>
+        <p:style>
+          <a:lnRef idx="1">
+            <a:schemeClr val="accent1"/>
+          </a:lnRef>
+          <a:fillRef idx="3">
+            <a:schemeClr val="accent1"/>
+          </a:fillRef>
+          <a:effectRef idx="2">
+            <a:schemeClr val="accent1"/>
+          </a:effectRef>
+          <a:fontRef idx="minor">
+            <a:schemeClr val="lt1"/>
+          </a:fontRef>
+        </p:style>
+        <p:txBody>
+          <a:bodyPr rtlCol="0" anchor="ctr"/>
+          <a:lstStyle/>
+          <a:p>
+            <a:pPr algn="ctr"/>
+          </a:p>
+        </p:txBody>
+      </p:sp>
+      <p:pic>
+        <p:nvPicPr>
+          <p:cNvPr id="13" name="Screenshot dark" descr="dark"/>
+          <p:cNvPicPr>
+            <a:picLocks noChangeAspect="1"/>
+          </p:cNvPicPr>
+          <p:nvPr/>
+        </p:nvPicPr>
+        <p:blipFill>
+          <a:blip r:embed="rId3"/>
+          <a:stretch>
+            <a:fillRect/>
+          </a:stretch>
+        </p:blipFill>
+        <p:spPr>
+          <a:xfrm>
+            <a:off x="9646920" y="2148840"/>
+            <a:ext cx="1920240" cy="3801090"/>
+          </a:xfrm>
+          <a:prstGeom prst="roundRect">
+            <a:avLst>
+              <a:gd name="adj" fmla="val 6000"/>
+            </a:avLst>
+          </a:prstGeom>
+          <a:ln w="28575">
+            <a:solidFill>
+              <a:srgbClr val="15302E"/>
+            </a:solidFill>
+          </a:ln>
+        </p:spPr>
+      </p:pic>
+      <p:sp>
+        <p:nvSpPr>
+          <p:cNvPr id="14" name="Footer"/>
+          <p:cNvSpPr txBox="1"/>
+          <p:nvPr/>
+        </p:nvSpPr>
+        <p:spPr>
+          <a:xfrm>
+            <a:off x="640080" y="6419088"/>
+            <a:ext cx="7772400" cy="274320"/>
+          </a:xfrm>
+          <a:prstGeom prst="rect">
+            <a:avLst/>
+          </a:prstGeom>
+          <a:noFill/>
+        </p:spPr>
+        <p:txBody>
+          <a:bodyPr wrap="square" anchor="ctr" lIns="0" rIns="0" tIns="0" bIns="0">
+            <a:spAutoFit/>
+          </a:bodyPr>
+          <a:lstStyle/>
+          <a:p>
+            <a:pPr algn="l"/>
+            <a:r>
+              <a:rPr sz="1050" b="0" lang="en-US">
+                <a:solidFill>
+                  <a:srgbClr val="5D716E"/>
+                </a:solidFill>
+                <a:latin typeface="Calibri"/>
+                <a:cs typeface="Calibri"/>
+              </a:rPr>
+              <a:t>Free · Non-commercial · marshadkc.github.io/quranreader</a:t>
+            </a:r>
+          </a:p>
+        </p:txBody>
+      </p:sp>
+      <p:sp>
+        <p:nvSpPr>
+          <p:cNvPr id="15" name="Slide number"/>
+          <p:cNvSpPr txBox="1"/>
+          <p:nvPr/>
+        </p:nvSpPr>
+        <p:spPr>
+          <a:xfrm>
+            <a:off x="10820095" y="6419088"/>
+            <a:ext cx="731520" cy="274320"/>
+          </a:xfrm>
+          <a:prstGeom prst="rect">
+            <a:avLst/>
+          </a:prstGeom>
+          <a:noFill/>
+        </p:spPr>
+        <p:txBody>
+          <a:bodyPr wrap="square" anchor="ctr" lIns="0" rIns="0" tIns="0" bIns="0">
+            <a:spAutoFit/>
+          </a:bodyPr>
+          <a:lstStyle/>
+          <a:p>
+            <a:pPr algn="r"/>
+            <a:r>
+              <a:rPr sz="1050" b="0" lang="en-US">
+                <a:solidFill>
+                  <a:srgbClr val="5D716E"/>
+                </a:solidFill>
+                <a:latin typeface="Calibri"/>
+                <a:cs typeface="Calibri"/>
+              </a:rPr>
+              <a:t>15</a:t>
+            </a:r>
+          </a:p>
+        </p:txBody>
+      </p:sp>
+    </p:spTree>
+  </p:cSld>
+  <p:clrMapOvr>
+    <a:masterClrMapping/>
+  </p:clrMapOvr>
+</p:sld>
+</file>
+
+<file path=ppt/slides/slide16.xml><?xml version="1.0" encoding="utf-8"?>
+<p:sld xmlns:a="http://schemas.openxmlformats.org/drawingml/2006/main" xmlns:p="http://schemas.openxmlformats.org/presentationml/2006/main" xmlns:r="http://schemas.openxmlformats.org/officeDocument/2006/relationships">
+  <p:cSld>
+    <p:bg>
+      <p:bgPr>
+        <a:solidFill>
+          <a:srgbClr val="F3F5F4"/>
+        </a:solidFill>
+        <a:effectLst/>
+      </p:bgPr>
+    </p:bg>
+    <p:spTree>
+      <p:nvGrpSpPr>
+        <p:cNvPr id="1" name=""/>
+        <p:cNvGrpSpPr/>
+        <p:nvPr/>
+      </p:nvGrpSpPr>
+      <p:grpSpPr/>
+      <p:sp>
+        <p:nvSpPr>
+          <p:cNvPr id="2" name="Number badge"/>
+          <p:cNvSpPr/>
+          <p:nvPr/>
+        </p:nvSpPr>
+        <p:spPr>
+          <a:xfrm>
+            <a:off x="640080" y="566928"/>
+            <a:ext cx="532546" cy="475488"/>
+          </a:xfrm>
+          <a:prstGeom prst="hexagon">
+            <a:avLst/>
+          </a:prstGeom>
+          <a:solidFill>
+            <a:srgbClr val="E9A227"/>
+          </a:solidFill>
+          <a:ln>
+            <a:noFill/>
+          </a:ln>
+          <a:effectLst/>
+        </p:spPr>
+        <p:style>
+          <a:lnRef idx="1">
+            <a:schemeClr val="accent1"/>
+          </a:lnRef>
+          <a:fillRef idx="3">
+            <a:schemeClr val="accent1"/>
+          </a:fillRef>
+          <a:effectRef idx="2">
+            <a:schemeClr val="accent1"/>
+          </a:effectRef>
+          <a:fontRef idx="minor">
+            <a:schemeClr val="lt1"/>
+          </a:fontRef>
+        </p:style>
+        <p:txBody>
+          <a:bodyPr rtlCol="0" anchor="ctr" lIns="0" rIns="0" tIns="0" bIns="0"/>
+          <a:lstStyle/>
+          <a:p>
+            <a:pPr algn="ctr"/>
+            <a:r>
+              <a:rPr sz="1300" b="1" lang="en-US">
+                <a:solidFill>
+                  <a:srgbClr val="FFFFFF"/>
+                </a:solidFill>
+                <a:latin typeface="Calibri"/>
+                <a:cs typeface="Calibri"/>
+              </a:rPr>
+              <a:t>14</a:t>
+            </a:r>
+          </a:p>
+        </p:txBody>
+      </p:sp>
+      <p:sp>
+        <p:nvSpPr>
+          <p:cNvPr id="3" name="Kicker"/>
+          <p:cNvSpPr txBox="1"/>
+          <p:nvPr/>
+        </p:nvSpPr>
+        <p:spPr>
+          <a:xfrm>
+            <a:off x="1325880" y="566928"/>
             <a:ext cx="9784080" cy="475488"/>
           </a:xfrm>
           <a:prstGeom prst="rect">
@@ -7907,7 +8488,7 @@
                 <a:latin typeface="Calibri"/>
                 <a:cs typeface="Calibri"/>
               </a:rPr>
-              <a:t>15</a:t>
+              <a:t>16</a:t>
             </a:r>
           </a:p>
         </p:txBody>
@@ -7920,7 +8501,7 @@
 </p:sld>
 </file>
 
-<file path=ppt/slides/slide16.xml><?xml version="1.0" encoding="utf-8"?>
+<file path=ppt/slides/slide17.xml><?xml version="1.0" encoding="utf-8"?>
 <p:sld xmlns:a="http://schemas.openxmlformats.org/drawingml/2006/main" xmlns:p="http://schemas.openxmlformats.org/presentationml/2006/main" xmlns:r="http://schemas.openxmlformats.org/officeDocument/2006/relationships">
   <p:cSld>
     <p:bg>
@@ -7987,7 +8568,7 @@
                 <a:latin typeface="Calibri"/>
                 <a:cs typeface="Calibri"/>
               </a:rPr>
-              <a:t>14</a:t>
+              <a:t>15</a:t>
             </a:r>
           </a:p>
         </p:txBody>
@@ -8547,7 +9128,7 @@
                 <a:latin typeface="Calibri"/>
                 <a:cs typeface="Calibri"/>
               </a:rPr>
-              <a:t>16</a:t>
+              <a:t>17</a:t>
             </a:r>
           </a:p>
         </p:txBody>

</xml_diff>